<commit_message>
docs: add NODE_ENV sandbox footgun warning to install guide Configure slide
Co-Authored-By: Claude Opus 4.8 (1M context) <noreply@anthropic.com>
</commit_message>
<xml_diff>
--- a/docs/Kadima-Medusa-Install-Guide.pptx
+++ b/docs/Kadima-Medusa-Install-Guide.pptx
@@ -7685,7 +7685,7 @@
         <p:spPr>
           <a:xfrm>
             <a:off x="548640" y="1645920"/>
-            <a:ext cx="7315200" cy="4297680"/>
+            <a:ext cx="7315200" cy="4069080"/>
           </a:xfrm>
           <a:prstGeom prst="rect">
             <a:avLst/>
@@ -7710,7 +7710,7 @@
         <p:spPr>
           <a:xfrm>
             <a:off x="777240" y="1810512"/>
-            <a:ext cx="6858000" cy="3968496"/>
+            <a:ext cx="6858000" cy="3739896"/>
           </a:xfrm>
           <a:prstGeom prst="rect">
             <a:avLst/>
@@ -8092,7 +8092,7 @@
         <p:spPr>
           <a:xfrm>
             <a:off x="8092440" y="1645920"/>
-            <a:ext cx="3547872" cy="4297680"/>
+            <a:ext cx="3547872" cy="4069080"/>
           </a:xfrm>
           <a:prstGeom prst="rect">
             <a:avLst/>
@@ -8436,9 +8436,117 @@
                 <a:ea typeface="Manrope" pitchFamily="34" charset="-122"/>
                 <a:cs typeface="Manrope" pitchFamily="34" charset="-120"/>
               </a:rPr>
-              <a:t>Keep sandbox: true until you've tested.</a:t>
+              <a:t>Set sandbox explicitly — sandbox: true to test, false for live.</a:t>
             </a:r>
             <a:endParaRPr lang="en-US" sz="1100" dirty="0"/>
+          </a:p>
+        </p:txBody>
+      </p:sp>
+      <p:sp>
+        <p:nvSpPr>
+          <p:cNvPr id="20" name="Shape 11"/>
+          <p:cNvSpPr/>
+          <p:nvPr/>
+        </p:nvSpPr>
+        <p:spPr>
+          <a:xfrm>
+            <a:off x="548640" y="5852160"/>
+            <a:ext cx="11091672" cy="548640"/>
+          </a:xfrm>
+          <a:prstGeom prst="rect">
+            <a:avLst/>
+          </a:prstGeom>
+          <a:solidFill>
+            <a:srgbClr val="2A1E0E"/>
+          </a:solidFill>
+          <a:ln w="12700">
+            <a:solidFill>
+              <a:srgbClr val="C98A2B"/>
+            </a:solidFill>
+            <a:prstDash val="solid"/>
+          </a:ln>
+        </p:spPr>
+      </p:sp>
+      <p:pic>
+        <p:nvPicPr>
+          <p:cNvPr id="21" name="Image 7" descr="preencoded.png">    </p:cNvPr>
+          <p:cNvPicPr>
+            <a:picLocks noChangeAspect="1"/>
+          </p:cNvPicPr>
+          <p:nvPr/>
+        </p:nvPicPr>
+        <p:blipFill>
+          <a:blip r:embed="rId8"/>
+          <a:stretch>
+            <a:fillRect/>
+          </a:stretch>
+        </p:blipFill>
+        <p:spPr>
+          <a:xfrm>
+            <a:off x="731520" y="5989320"/>
+            <a:ext cx="274320" cy="274320"/>
+          </a:xfrm>
+          <a:prstGeom prst="rect">
+            <a:avLst/>
+          </a:prstGeom>
+        </p:spPr>
+      </p:pic>
+      <p:sp>
+        <p:nvSpPr>
+          <p:cNvPr id="22" name="Text 12"/>
+          <p:cNvSpPr/>
+          <p:nvPr/>
+        </p:nvSpPr>
+        <p:spPr>
+          <a:xfrm>
+            <a:off x="1143000" y="5888736"/>
+            <a:ext cx="10332720" cy="475488"/>
+          </a:xfrm>
+          <a:prstGeom prst="rect">
+            <a:avLst/>
+          </a:prstGeom>
+          <a:noFill/>
+          <a:ln/>
+        </p:spPr>
+        <p:txBody>
+          <a:bodyPr wrap="square" rtlCol="0" anchor="ctr"/>
+          <a:lstStyle/>
+          <a:p>
+            <a:pPr indent="0" marL="0">
+              <a:lnSpc>
+                <a:spcPct val="100000"/>
+              </a:lnSpc>
+              <a:buNone/>
+            </a:pPr>
+            <a:r>
+              <a:rPr lang="en-US" sz="1050" b="1" dirty="0">
+                <a:solidFill>
+                  <a:srgbClr val="F0B454"/>
+                </a:solidFill>
+                <a:latin typeface="Manrope" pitchFamily="34" charset="0"/>
+                <a:ea typeface="Manrope" pitchFamily="34" charset="-122"/>
+                <a:cs typeface="Manrope" pitchFamily="34" charset="-120"/>
+              </a:rPr>
+              <a:t>Don't derive sandbox from NODE_ENV</a:t>
+            </a:r>
+            <a:pPr indent="0" marL="0">
+              <a:lnSpc>
+                <a:spcPct val="100000"/>
+              </a:lnSpc>
+              <a:buNone/>
+            </a:pPr>
+            <a:r>
+              <a:rPr lang="en-US" sz="1050" dirty="0">
+                <a:solidFill>
+                  <a:srgbClr val="CFD6DD"/>
+                </a:solidFill>
+                <a:latin typeface="Manrope" pitchFamily="34" charset="0"/>
+                <a:ea typeface="Manrope" pitchFamily="34" charset="-122"/>
+                <a:cs typeface="Manrope" pitchFamily="34" charset="-120"/>
+              </a:rPr>
+              <a:t> — Railway/Render/Vercel set NODE_ENV=production, which sends sandbox creds to the live host (401). The plugin logs its resolved host + sandbox + token on startup — check that first.</a:t>
+            </a:r>
+            <a:endParaRPr lang="en-US" sz="1050" dirty="0"/>
           </a:p>
         </p:txBody>
       </p:sp>

</xml_diff>

<commit_message>
docs: propagate Hosted Fields requirements into all merchant decks
Install guide: add api-creditcard-payment-read-write scope (credentials step),
storeUrl in the Configure code + notes, and amount={cart.total} (no /100) on the
checkout step; refresh the PDF. Onboarding + master decks: add storeUrl to the
kadima-card config snippet so they don't contradict the install guide.

Co-Authored-By: Claude Opus 4.8 (1M context) <noreply@anthropic.com>
</commit_message>
<xml_diff>
--- a/docs/Kadima-Medusa-Install-Guide.pptx
+++ b/docs/Kadima-Medusa-Install-Guide.pptx
@@ -6794,27 +6794,27 @@
         </p:nvSpPr>
         <p:spPr>
           <a:xfrm>
-            <a:off x="6903720" y="5440680"/>
-            <a:ext cx="4526280" cy="384048"/>
-          </a:xfrm>
-          <a:prstGeom prst="rect">
-            <a:avLst/>
-          </a:prstGeom>
-          <a:noFill/>
-          <a:ln/>
-        </p:spPr>
-        <p:txBody>
-          <a:bodyPr wrap="square" rtlCol="0" anchor="ctr"/>
+            <a:off x="6903720" y="5285232"/>
+            <a:ext cx="4526280" cy="566928"/>
+          </a:xfrm>
+          <a:prstGeom prst="rect">
+            <a:avLst/>
+          </a:prstGeom>
+          <a:noFill/>
+          <a:ln/>
+        </p:spPr>
+        <p:txBody>
+          <a:bodyPr wrap="square" rtlCol="0" anchor="t"/>
           <a:lstStyle/>
           <a:p>
             <a:pPr indent="0" marL="0">
               <a:lnSpc>
-                <a:spcPct val="105000"/>
+                <a:spcPct val="106000"/>
               </a:lnSpc>
               <a:buNone/>
             </a:pPr>
             <a:r>
-              <a:rPr lang="en-US" sz="1050" i="1" dirty="0">
+              <a:rPr lang="en-US" sz="1000" dirty="0">
                 <a:solidFill>
                   <a:srgbClr val="8A93A0"/>
                 </a:solidFill>
@@ -6822,9 +6822,43 @@
                 <a:ea typeface="Manrope" pitchFamily="34" charset="-122"/>
                 <a:cs typeface="Manrope" pitchFamily="34" charset="-120"/>
               </a:rPr>
-              <a:t>Enable all of them so cards, ACH, saved cards and webhooks all work.</a:t>
-            </a:r>
-            <a:endParaRPr lang="en-US" sz="1050" dirty="0"/>
+              <a:t>Card payments need the </a:t>
+            </a:r>
+            <a:pPr indent="0" marL="0">
+              <a:lnSpc>
+                <a:spcPct val="106000"/>
+              </a:lnSpc>
+              <a:buNone/>
+            </a:pPr>
+            <a:r>
+              <a:rPr lang="en-US" sz="1000" dirty="0">
+                <a:solidFill>
+                  <a:srgbClr val="27A9E2"/>
+                </a:solidFill>
+                <a:latin typeface="Consolas" pitchFamily="34" charset="0"/>
+                <a:ea typeface="Consolas" pitchFamily="34" charset="-122"/>
+                <a:cs typeface="Consolas" pitchFamily="34" charset="-120"/>
+              </a:rPr>
+              <a:t>api-creditcard-payment-read-write</a:t>
+            </a:r>
+            <a:pPr indent="0" marL="0">
+              <a:lnSpc>
+                <a:spcPct val="106000"/>
+              </a:lnSpc>
+              <a:buNone/>
+            </a:pPr>
+            <a:r>
+              <a:rPr lang="en-US" sz="1000" dirty="0">
+                <a:solidFill>
+                  <a:srgbClr val="8A93A0"/>
+                </a:solidFill>
+                <a:latin typeface="Manrope" pitchFamily="34" charset="0"/>
+                <a:ea typeface="Manrope" pitchFamily="34" charset="-122"/>
+                <a:cs typeface="Manrope" pitchFamily="34" charset="-120"/>
+              </a:rPr>
+              <a:t> scope. Enable all available so ACH, saved cards &amp; webhooks work too.</a:t>
+            </a:r>
+            <a:endParaRPr lang="en-US" sz="1000" dirty="0"/>
           </a:p>
         </p:txBody>
       </p:sp>
@@ -7937,7 +7971,47 @@
                 <a:ea typeface="Consolas" pitchFamily="34" charset="-122"/>
                 <a:cs typeface="Consolas" pitchFamily="34" charset="-120"/>
               </a:rPr>
-              <a:t>        captureMethod: "auth", sandbox: true } },</a:t>
+              <a:t>        captureMethod: "auth",</a:t>
+            </a:r>
+            <a:endParaRPr lang="en-US" sz="1050" dirty="0"/>
+          </a:p>
+          <a:p>
+            <a:pPr indent="0" marL="0">
+              <a:lnSpc>
+                <a:spcPct val="114000"/>
+              </a:lnSpc>
+              <a:buNone/>
+            </a:pPr>
+            <a:r>
+              <a:rPr lang="en-US" sz="1050" dirty="0">
+                <a:solidFill>
+                  <a:srgbClr val="27A9E2"/>
+                </a:solidFill>
+                <a:latin typeface="Consolas" pitchFamily="34" charset="0"/>
+                <a:ea typeface="Consolas" pitchFamily="34" charset="-122"/>
+                <a:cs typeface="Consolas" pitchFamily="34" charset="-120"/>
+              </a:rPr>
+              <a:t>        storeUrl: process.env.KADIMA_STORE_URL, // your storefront URL</a:t>
+            </a:r>
+            <a:endParaRPr lang="en-US" sz="1050" dirty="0"/>
+          </a:p>
+          <a:p>
+            <a:pPr indent="0" marL="0">
+              <a:lnSpc>
+                <a:spcPct val="114000"/>
+              </a:lnSpc>
+              <a:buNone/>
+            </a:pPr>
+            <a:r>
+              <a:rPr lang="en-US" sz="1050" dirty="0">
+                <a:solidFill>
+                  <a:srgbClr val="CFD6DD"/>
+                </a:solidFill>
+                <a:latin typeface="Consolas" pitchFamily="34" charset="0"/>
+                <a:ea typeface="Consolas" pitchFamily="34" charset="-122"/>
+                <a:cs typeface="Consolas" pitchFamily="34" charset="-120"/>
+              </a:rPr>
+              <a:t>        sandbox: true } },</a:t>
             </a:r>
             <a:endParaRPr lang="en-US" sz="1050" dirty="0"/>
           </a:p>
@@ -8238,7 +8312,7 @@
                 <a:ea typeface="Manrope" pitchFamily="34" charset="-122"/>
                 <a:cs typeface="Manrope" pitchFamily="34" charset="-120"/>
               </a:rPr>
-              <a:t>Put your Kadima values in .env.</a:t>
+              <a:t>Put your Kadima values + storeUrl (your storefront URL) in .env.</a:t>
             </a:r>
             <a:endParaRPr lang="en-US" sz="1100" dirty="0"/>
           </a:p>
@@ -8304,7 +8378,7 @@
                 <a:ea typeface="Manrope" pitchFamily="34" charset="-122"/>
                 <a:cs typeface="Manrope" pitchFamily="34" charset="-120"/>
               </a:rPr>
-              <a:t>Enable both providers in your region / sales channel.</a:t>
+              <a:t>storeUrl must match where the storefront runs — Hosted Fields locks to it.</a:t>
             </a:r>
             <a:endParaRPr lang="en-US" sz="1100" dirty="0"/>
           </a:p>
@@ -9184,6 +9258,73 @@
               <a:t>KadimaHostedFields.tsx   KadimaAchForm.tsx   README.md  (wiring guide)</a:t>
             </a:r>
             <a:endParaRPr lang="en-US" sz="1100" dirty="0"/>
+          </a:p>
+        </p:txBody>
+      </p:sp>
+      <p:sp>
+        <p:nvSpPr>
+          <p:cNvPr id="20" name="Text 14"/>
+          <p:cNvSpPr/>
+          <p:nvPr/>
+        </p:nvSpPr>
+        <p:spPr>
+          <a:xfrm>
+            <a:off x="566928" y="5806440"/>
+            <a:ext cx="10972800" cy="365760"/>
+          </a:xfrm>
+          <a:prstGeom prst="rect">
+            <a:avLst/>
+          </a:prstGeom>
+          <a:noFill/>
+          <a:ln/>
+        </p:spPr>
+        <p:txBody>
+          <a:bodyPr wrap="square" rtlCol="0" anchor="ctr"/>
+          <a:lstStyle/>
+          <a:p>
+            <a:pPr indent="0" marL="0">
+              <a:buNone/>
+            </a:pPr>
+            <a:r>
+              <a:rPr lang="en-US" sz="1050" dirty="0">
+                <a:solidFill>
+                  <a:srgbClr val="8A93A0"/>
+                </a:solidFill>
+                <a:latin typeface="Manrope" pitchFamily="34" charset="0"/>
+                <a:ea typeface="Manrope" pitchFamily="34" charset="-122"/>
+                <a:cs typeface="Manrope" pitchFamily="34" charset="-120"/>
+              </a:rPr>
+              <a:t>Pass </a:t>
+            </a:r>
+            <a:pPr indent="0" marL="0">
+              <a:buNone/>
+            </a:pPr>
+            <a:r>
+              <a:rPr lang="en-US" sz="1050" dirty="0">
+                <a:solidFill>
+                  <a:srgbClr val="27A9E2"/>
+                </a:solidFill>
+                <a:latin typeface="Consolas" pitchFamily="34" charset="0"/>
+                <a:ea typeface="Consolas" pitchFamily="34" charset="-122"/>
+                <a:cs typeface="Consolas" pitchFamily="34" charset="-120"/>
+              </a:rPr>
+              <a:t>amount={cart.total}</a:t>
+            </a:r>
+            <a:pPr indent="0" marL="0">
+              <a:buNone/>
+            </a:pPr>
+            <a:r>
+              <a:rPr lang="en-US" sz="1050" dirty="0">
+                <a:solidFill>
+                  <a:srgbClr val="8A93A0"/>
+                </a:solidFill>
+                <a:latin typeface="Manrope" pitchFamily="34" charset="0"/>
+                <a:ea typeface="Manrope" pitchFamily="34" charset="-122"/>
+                <a:cs typeface="Manrope" pitchFamily="34" charset="-120"/>
+              </a:rPr>
+              <a:t> to KadimaHostedFields — Medusa v2 totals are already in dollars, so don't divide by 100.</a:t>
+            </a:r>
+            <a:endParaRPr lang="en-US" sz="1050" dirty="0"/>
           </a:p>
         </p:txBody>
       </p:sp>

</xml_diff>